<commit_message>
Acrescentado tabela comprovando a maior amostragem nos veículos que possuem um maior km
</commit_message>
<xml_diff>
--- a/Apresentação.pptx
+++ b/Apresentação.pptx
@@ -105,6 +105,11 @@
       </a:defRPr>
     </a:lvl9pPr>
   </p:defaultTextStyle>
+  <p:extLst>
+    <p:ext uri="{EFAFB233-063F-42B5-8137-9DF3F51BA10A}">
+      <p15:sldGuideLst xmlns:p15="http://schemas.microsoft.com/office/powerpoint/2012/main"/>
+    </p:ext>
+  </p:extLst>
 </p:presentation>
 </file>
 
@@ -255,7 +260,7 @@
           <a:p>
             <a:fld id="{71E8E3D3-3DB8-4544-ACB3-3D058B70E0E1}" type="datetimeFigureOut">
               <a:rPr lang="pt-BR" smtClean="0"/>
-              <a:t>02/05/2026</a:t>
+              <a:t>04/05/2026</a:t>
             </a:fld>
             <a:endParaRPr lang="pt-BR"/>
           </a:p>
@@ -453,7 +458,7 @@
           <a:p>
             <a:fld id="{71E8E3D3-3DB8-4544-ACB3-3D058B70E0E1}" type="datetimeFigureOut">
               <a:rPr lang="pt-BR" smtClean="0"/>
-              <a:t>02/05/2026</a:t>
+              <a:t>04/05/2026</a:t>
             </a:fld>
             <a:endParaRPr lang="pt-BR"/>
           </a:p>
@@ -661,7 +666,7 @@
           <a:p>
             <a:fld id="{71E8E3D3-3DB8-4544-ACB3-3D058B70E0E1}" type="datetimeFigureOut">
               <a:rPr lang="pt-BR" smtClean="0"/>
-              <a:t>02/05/2026</a:t>
+              <a:t>04/05/2026</a:t>
             </a:fld>
             <a:endParaRPr lang="pt-BR"/>
           </a:p>
@@ -859,7 +864,7 @@
           <a:p>
             <a:fld id="{71E8E3D3-3DB8-4544-ACB3-3D058B70E0E1}" type="datetimeFigureOut">
               <a:rPr lang="pt-BR" smtClean="0"/>
-              <a:t>02/05/2026</a:t>
+              <a:t>04/05/2026</a:t>
             </a:fld>
             <a:endParaRPr lang="pt-BR"/>
           </a:p>
@@ -1134,7 +1139,7 @@
           <a:p>
             <a:fld id="{71E8E3D3-3DB8-4544-ACB3-3D058B70E0E1}" type="datetimeFigureOut">
               <a:rPr lang="pt-BR" smtClean="0"/>
-              <a:t>02/05/2026</a:t>
+              <a:t>04/05/2026</a:t>
             </a:fld>
             <a:endParaRPr lang="pt-BR"/>
           </a:p>
@@ -1399,7 +1404,7 @@
           <a:p>
             <a:fld id="{71E8E3D3-3DB8-4544-ACB3-3D058B70E0E1}" type="datetimeFigureOut">
               <a:rPr lang="pt-BR" smtClean="0"/>
-              <a:t>02/05/2026</a:t>
+              <a:t>04/05/2026</a:t>
             </a:fld>
             <a:endParaRPr lang="pt-BR"/>
           </a:p>
@@ -1811,7 +1816,7 @@
           <a:p>
             <a:fld id="{71E8E3D3-3DB8-4544-ACB3-3D058B70E0E1}" type="datetimeFigureOut">
               <a:rPr lang="pt-BR" smtClean="0"/>
-              <a:t>02/05/2026</a:t>
+              <a:t>04/05/2026</a:t>
             </a:fld>
             <a:endParaRPr lang="pt-BR"/>
           </a:p>
@@ -1952,7 +1957,7 @@
           <a:p>
             <a:fld id="{71E8E3D3-3DB8-4544-ACB3-3D058B70E0E1}" type="datetimeFigureOut">
               <a:rPr lang="pt-BR" smtClean="0"/>
-              <a:t>02/05/2026</a:t>
+              <a:t>04/05/2026</a:t>
             </a:fld>
             <a:endParaRPr lang="pt-BR"/>
           </a:p>
@@ -2065,7 +2070,7 @@
           <a:p>
             <a:fld id="{71E8E3D3-3DB8-4544-ACB3-3D058B70E0E1}" type="datetimeFigureOut">
               <a:rPr lang="pt-BR" smtClean="0"/>
-              <a:t>02/05/2026</a:t>
+              <a:t>04/05/2026</a:t>
             </a:fld>
             <a:endParaRPr lang="pt-BR"/>
           </a:p>
@@ -2376,7 +2381,7 @@
           <a:p>
             <a:fld id="{71E8E3D3-3DB8-4544-ACB3-3D058B70E0E1}" type="datetimeFigureOut">
               <a:rPr lang="pt-BR" smtClean="0"/>
-              <a:t>02/05/2026</a:t>
+              <a:t>04/05/2026</a:t>
             </a:fld>
             <a:endParaRPr lang="pt-BR"/>
           </a:p>
@@ -2664,7 +2669,7 @@
           <a:p>
             <a:fld id="{71E8E3D3-3DB8-4544-ACB3-3D058B70E0E1}" type="datetimeFigureOut">
               <a:rPr lang="pt-BR" smtClean="0"/>
-              <a:t>02/05/2026</a:t>
+              <a:t>04/05/2026</a:t>
             </a:fld>
             <a:endParaRPr lang="pt-BR"/>
           </a:p>
@@ -2905,7 +2910,7 @@
           <a:p>
             <a:fld id="{71E8E3D3-3DB8-4544-ACB3-3D058B70E0E1}" type="datetimeFigureOut">
               <a:rPr lang="pt-BR" smtClean="0"/>
-              <a:t>02/05/2026</a:t>
+              <a:t>04/05/2026</a:t>
             </a:fld>
             <a:endParaRPr lang="pt-BR"/>
           </a:p>
@@ -3400,14 +3405,14 @@
           <p:nvPr>
             <p:extLst>
               <p:ext uri="{D42A27DB-BD31-4B8C-83A1-F6EECF244321}">
-                <p14:modId xmlns:p14="http://schemas.microsoft.com/office/powerpoint/2010/main" val="3614952286"/>
+                <p14:modId xmlns:p14="http://schemas.microsoft.com/office/powerpoint/2010/main" val="2052981966"/>
               </p:ext>
             </p:extLst>
           </p:nvPr>
         </p:nvGraphicFramePr>
         <p:xfrm>
-          <a:off x="420688" y="3722688"/>
-          <a:ext cx="5349875" cy="2835275"/>
+          <a:off x="420688" y="3819646"/>
+          <a:ext cx="5349875" cy="2738317"/>
         </p:xfrm>
         <a:graphic>
           <a:graphicData uri="http://schemas.openxmlformats.org/presentationml/2006/ole">
@@ -3434,8 +3439,8 @@
                     </p:blipFill>
                     <p:spPr>
                       <a:xfrm>
-                        <a:off x="420688" y="3722688"/>
-                        <a:ext cx="5349875" cy="2835275"/>
+                        <a:off x="420688" y="3819646"/>
+                        <a:ext cx="5349875" cy="2738317"/>
                       </a:xfrm>
                       <a:prstGeom prst="rect">
                         <a:avLst/>
@@ -3463,13 +3468,13 @@
           <p:nvPr>
             <p:extLst>
               <p:ext uri="{D42A27DB-BD31-4B8C-83A1-F6EECF244321}">
-                <p14:modId xmlns:p14="http://schemas.microsoft.com/office/powerpoint/2010/main" val="262372785"/>
+                <p14:modId xmlns:p14="http://schemas.microsoft.com/office/powerpoint/2010/main" val="3256955853"/>
               </p:ext>
             </p:extLst>
           </p:nvPr>
         </p:nvGraphicFramePr>
         <p:xfrm>
-          <a:off x="415925" y="746125"/>
+          <a:off x="384175" y="904113"/>
           <a:ext cx="11423650" cy="2835275"/>
         </p:xfrm>
         <a:graphic>
@@ -3497,7 +3502,7 @@
                     </p:blipFill>
                     <p:spPr>
                       <a:xfrm>
-                        <a:off x="415925" y="746125"/>
+                        <a:off x="384175" y="904113"/>
                         <a:ext cx="11423650" cy="2835275"/>
                       </a:xfrm>
                       <a:prstGeom prst="rect">
@@ -3526,14 +3531,14 @@
           <p:nvPr>
             <p:extLst>
               <p:ext uri="{D42A27DB-BD31-4B8C-83A1-F6EECF244321}">
-                <p14:modId xmlns:p14="http://schemas.microsoft.com/office/powerpoint/2010/main" val="614425938"/>
+                <p14:modId xmlns:p14="http://schemas.microsoft.com/office/powerpoint/2010/main" val="3574404428"/>
               </p:ext>
             </p:extLst>
           </p:nvPr>
         </p:nvGraphicFramePr>
         <p:xfrm>
-          <a:off x="5989638" y="3727450"/>
-          <a:ext cx="5845175" cy="2830513"/>
+          <a:off x="5989638" y="3819646"/>
+          <a:ext cx="5845175" cy="2738317"/>
         </p:xfrm>
         <a:graphic>
           <a:graphicData uri="http://schemas.openxmlformats.org/presentationml/2006/ole">
@@ -3560,8 +3565,77 @@
                     </p:blipFill>
                     <p:spPr>
                       <a:xfrm>
-                        <a:off x="5989638" y="3727450"/>
-                        <a:ext cx="5845175" cy="2830513"/>
+                        <a:off x="5989638" y="3819646"/>
+                        <a:ext cx="5845175" cy="2738317"/>
+                      </a:xfrm>
+                      <a:prstGeom prst="rect">
+                        <a:avLst/>
+                      </a:prstGeom>
+                    </p:spPr>
+                  </p:pic>
+                </p:oleObj>
+              </mc:Fallback>
+            </mc:AlternateContent>
+          </a:graphicData>
+        </a:graphic>
+      </p:graphicFrame>
+      <p:graphicFrame>
+        <p:nvGraphicFramePr>
+          <p:cNvPr id="3" name="Objeto 2">
+            <a:extLst>
+              <a:ext uri="{FF2B5EF4-FFF2-40B4-BE49-F238E27FC236}">
+                <a16:creationId xmlns:a16="http://schemas.microsoft.com/office/drawing/2014/main" id="{3DDB2F5B-7D5C-E530-EA12-AFCEA8598AEC}"/>
+              </a:ext>
+            </a:extLst>
+          </p:cNvPr>
+          <p:cNvGraphicFramePr>
+            <a:graphicFrameLocks noChangeAspect="1"/>
+          </p:cNvGraphicFramePr>
+          <p:nvPr>
+            <p:extLst>
+              <p:ext uri="{D42A27DB-BD31-4B8C-83A1-F6EECF244321}">
+                <p14:modId xmlns:p14="http://schemas.microsoft.com/office/powerpoint/2010/main" val="3558226879"/>
+              </p:ext>
+            </p:extLst>
+          </p:nvPr>
+        </p:nvGraphicFramePr>
+        <p:xfrm>
+          <a:off x="7088187" y="5385"/>
+          <a:ext cx="4127681" cy="816418"/>
+        </p:xfrm>
+        <a:graphic>
+          <a:graphicData uri="http://schemas.openxmlformats.org/presentationml/2006/ole">
+            <mc:AlternateContent xmlns:mc="http://schemas.openxmlformats.org/markup-compatibility/2006">
+              <mc:Choice xmlns:v="urn:schemas-microsoft-com:vml" Requires="v">
+                <p:oleObj name="Worksheet" r:id="rId10" imgW="3648240" imgH="771525" progId="Excel.Sheet.12">
+                  <p:link updateAutomatic="1"/>
+                </p:oleObj>
+              </mc:Choice>
+              <mc:Fallback>
+                <p:oleObj name="Worksheet" r:id="rId10" imgW="3648240" imgH="771525" progId="Excel.Sheet.12">
+                  <p:link updateAutomatic="1"/>
+                  <p:pic>
+                    <p:nvPicPr>
+                      <p:cNvPr id="2" name="Objeto 1">
+                        <a:extLst>
+                          <a:ext uri="{FF2B5EF4-FFF2-40B4-BE49-F238E27FC236}">
+                            <a16:creationId xmlns:a16="http://schemas.microsoft.com/office/drawing/2014/main" id="{3DDB2F5B-7D5C-E530-EA12-AFCEA8598AEC}"/>
+                          </a:ext>
+                        </a:extLst>
+                      </p:cNvPr>
+                      <p:cNvPicPr/>
+                      <p:nvPr/>
+                    </p:nvPicPr>
+                    <p:blipFill>
+                      <a:blip r:embed="rId11"/>
+                      <a:stretch>
+                        <a:fillRect/>
+                      </a:stretch>
+                    </p:blipFill>
+                    <p:spPr>
+                      <a:xfrm>
+                        <a:off x="7088187" y="5385"/>
+                        <a:ext cx="4127681" cy="816418"/>
                       </a:xfrm>
                       <a:prstGeom prst="rect">
                         <a:avLst/>

</xml_diff>